<commit_message>
Keep active dashboard and model workflows; archive historical experiments
</commit_message>
<xml_diff>
--- a/project/docs/delivery/GlucoTwin_Presentation.pptx
+++ b/project/docs/delivery/GlucoTwin_Presentation.pptx
@@ -2,24 +2,24 @@
 <file path=ppt/presentation.xml><?xml version="1.0" encoding="utf-8"?>
 <p:presentation xmlns:p="http://schemas.openxmlformats.org/presentationml/2006/main">
   <p:sldMasterIdLst>
-    <p:sldMasterId xmlns:r="http://schemas.openxmlformats.org/officeDocument/2006/relationships" id="2147483648" r:id="R771a94f3d9a147d1"/>
+    <p:sldMasterId xmlns:r="http://schemas.openxmlformats.org/officeDocument/2006/relationships" id="2147483648" r:id="Ra80074f5451c4745"/>
   </p:sldMasterIdLst>
   <p:notesMasterIdLst>
-    <p:notesMasterId xmlns:r="http://schemas.openxmlformats.org/officeDocument/2006/relationships" r:id="Rb6741e80803f4e92"/>
+    <p:notesMasterId xmlns:r="http://schemas.openxmlformats.org/officeDocument/2006/relationships" r:id="Rd9eed1b47f944bfe"/>
   </p:notesMasterIdLst>
   <p:sldIdLst>
-    <p:sldId xmlns:r="http://schemas.openxmlformats.org/officeDocument/2006/relationships" id="256" r:id="Rf8db58e780aa4058"/>
-    <p:sldId xmlns:r="http://schemas.openxmlformats.org/officeDocument/2006/relationships" id="257" r:id="R5ab04a1ecbfb49d0"/>
-    <p:sldId xmlns:r="http://schemas.openxmlformats.org/officeDocument/2006/relationships" id="258" r:id="R449d938595454589"/>
-    <p:sldId xmlns:r="http://schemas.openxmlformats.org/officeDocument/2006/relationships" id="259" r:id="Rb01b29ff8dbb4194"/>
-    <p:sldId xmlns:r="http://schemas.openxmlformats.org/officeDocument/2006/relationships" id="260" r:id="R16e7ee52a92c438c"/>
-    <p:sldId xmlns:r="http://schemas.openxmlformats.org/officeDocument/2006/relationships" id="261" r:id="Rd7a88aaffacb40d8"/>
-    <p:sldId xmlns:r="http://schemas.openxmlformats.org/officeDocument/2006/relationships" id="262" r:id="R6d1b0011a1fb461d"/>
-    <p:sldId xmlns:r="http://schemas.openxmlformats.org/officeDocument/2006/relationships" id="263" r:id="R7148efa59ef74a70"/>
-    <p:sldId xmlns:r="http://schemas.openxmlformats.org/officeDocument/2006/relationships" id="264" r:id="Rd8b411e3d08643f2"/>
-    <p:sldId xmlns:r="http://schemas.openxmlformats.org/officeDocument/2006/relationships" id="265" r:id="R1689897fc3f643a5"/>
-    <p:sldId xmlns:r="http://schemas.openxmlformats.org/officeDocument/2006/relationships" id="266" r:id="R0ef4377fcad84599"/>
-    <p:sldId xmlns:r="http://schemas.openxmlformats.org/officeDocument/2006/relationships" id="267" r:id="R437dc135ac384bfc"/>
+    <p:sldId xmlns:r="http://schemas.openxmlformats.org/officeDocument/2006/relationships" id="256" r:id="Re19fa5ebd59448bf"/>
+    <p:sldId xmlns:r="http://schemas.openxmlformats.org/officeDocument/2006/relationships" id="257" r:id="R97028bd6b7d34a69"/>
+    <p:sldId xmlns:r="http://schemas.openxmlformats.org/officeDocument/2006/relationships" id="258" r:id="R7d0adc71a6264f71"/>
+    <p:sldId xmlns:r="http://schemas.openxmlformats.org/officeDocument/2006/relationships" id="259" r:id="R0e1ffd446e334c75"/>
+    <p:sldId xmlns:r="http://schemas.openxmlformats.org/officeDocument/2006/relationships" id="260" r:id="R2f5f49f052bc482e"/>
+    <p:sldId xmlns:r="http://schemas.openxmlformats.org/officeDocument/2006/relationships" id="261" r:id="R9b27057d99a64b1a"/>
+    <p:sldId xmlns:r="http://schemas.openxmlformats.org/officeDocument/2006/relationships" id="262" r:id="R2cc5ff962a27447b"/>
+    <p:sldId xmlns:r="http://schemas.openxmlformats.org/officeDocument/2006/relationships" id="263" r:id="R122e3fead6504fb7"/>
+    <p:sldId xmlns:r="http://schemas.openxmlformats.org/officeDocument/2006/relationships" id="264" r:id="Rfefa2a2b2ac84ed8"/>
+    <p:sldId xmlns:r="http://schemas.openxmlformats.org/officeDocument/2006/relationships" id="265" r:id="Ra8400544a41b4b88"/>
+    <p:sldId xmlns:r="http://schemas.openxmlformats.org/officeDocument/2006/relationships" id="266" r:id="R724372c5a2af483f"/>
+    <p:sldId xmlns:r="http://schemas.openxmlformats.org/officeDocument/2006/relationships" id="267" r:id="Re221093c838a43d8"/>
   </p:sldIdLst>
   <p:sldSz cx="12192000" cy="6858000"/>
   <p:notesSz cx="6858000" cy="9144000"/>
@@ -453,7 +453,7 @@
           <a:lstStyle xmlns:a="http://schemas.openxmlformats.org/drawingml/2006/main"/>
           <a:p xmlns:a="http://schemas.openxmlformats.org/drawingml/2006/main">
             <a:r>
-              <a:t>Source: project/README.md</a:t>
+              <a:t>Source: README.md</a:t>
             </a:r>
           </a:p>
           <a:p xmlns:a="http://schemas.openxmlformats.org/drawingml/2006/main">
@@ -528,7 +528,7 @@
           <a:lstStyle xmlns:a="http://schemas.openxmlformats.org/drawingml/2006/main"/>
           <a:p xmlns:a="http://schemas.openxmlformats.org/drawingml/2006/main">
             <a:r>
-              <a:t>Source: project/docs/DCLP3_STUDY_V2.md; project/reports/dclp3_study_v2_checks.json</a:t>
+              <a:t>Source: project/docs/RESULTS.md; project/docs/FUSION.md</a:t>
             </a:r>
           </a:p>
           <a:p xmlns:a="http://schemas.openxmlformats.org/drawingml/2006/main">
@@ -603,7 +603,7 @@
           <a:lstStyle xmlns:a="http://schemas.openxmlformats.org/drawingml/2006/main"/>
           <a:p xmlns:a="http://schemas.openxmlformats.org/drawingml/2006/main">
             <a:r>
-              <a:t>Source: project/docs/INDEPENDENT_REVIEW_ACTIONS.md; project/docs/SCORE_IMPROVEMENT.md; project/docs/DCLP3_STUDY_V2.md</a:t>
+              <a:t>Source: project/docs/RESULTS.md; project/DATA_CONTRACT.md; project/EVALUATION_PROTOCOL.md</a:t>
             </a:r>
           </a:p>
           <a:p xmlns:a="http://schemas.openxmlformats.org/drawingml/2006/main">
@@ -678,7 +678,7 @@
           <a:lstStyle xmlns:a="http://schemas.openxmlformats.org/drawingml/2006/main"/>
           <a:p xmlns:a="http://schemas.openxmlformats.org/drawingml/2006/main">
             <a:r>
-              <a:t>Source: project/docs/REPRODUCTION.md; project/docs/DELIVERY_READINESS.md; project/README.md; project/LICENSE</a:t>
+              <a:t>Source: project/docs/REPRODUCTION.md; README.md; project/LICENSE</a:t>
             </a:r>
           </a:p>
           <a:p xmlns:a="http://schemas.openxmlformats.org/drawingml/2006/main">
@@ -828,7 +828,7 @@
           <a:lstStyle xmlns:a="http://schemas.openxmlformats.org/drawingml/2006/main"/>
           <a:p xmlns:a="http://schemas.openxmlformats.org/drawingml/2006/main">
             <a:r>
-              <a:t>Source: project/README.md; project/docs/FUSION.md</a:t>
+              <a:t>Source: README.md; project/docs/FUSION.md</a:t>
             </a:r>
           </a:p>
           <a:p xmlns:a="http://schemas.openxmlformats.org/drawingml/2006/main">
@@ -1203,7 +1203,7 @@
           <a:lstStyle xmlns:a="http://schemas.openxmlformats.org/drawingml/2006/main"/>
           <a:p xmlns:a="http://schemas.openxmlformats.org/drawingml/2006/main">
             <a:r>
-              <a:t>Source: project/src/glucotwin/episodes.py; project/src/glucotwin/event_study.py; project/reports/EVENT_STUDY_GPU_V2.md</a:t>
+              <a:t>Source: project/src/glucotwin/episodes.py; project/src/glucotwin/event_study.py; project/docs/RESULTS.md</a:t>
             </a:r>
           </a:p>
           <a:p xmlns:a="http://schemas.openxmlformats.org/drawingml/2006/main">
@@ -1278,7 +1278,7 @@
           <a:lstStyle xmlns:a="http://schemas.openxmlformats.org/drawingml/2006/main"/>
           <a:p xmlns:a="http://schemas.openxmlformats.org/drawingml/2006/main">
             <a:r>
-              <a:t>Source: project/reports/EVENT_STUDY_GPU_V2.md; project/docs/EVENT_RESEARCH_PROGRESS.md</a:t>
+              <a:t>Source: project/reports/event_study_gpu_v2.json; project/docs/RESULTS.md</a:t>
             </a:r>
           </a:p>
           <a:p xmlns:a="http://schemas.openxmlformats.org/drawingml/2006/main">
@@ -1330,7 +1330,7 @@
           <p:cNvPr id="3" name="Title">
             <a:extLst xmlns:a="http://schemas.openxmlformats.org/drawingml/2006/main">
               <a:ext uri="{FF2B5EF4-FFF2-40B4-BE49-F238E27FC236}">
-                <a16:creationId xmlns:a16="http://schemas.microsoft.com/office/drawing/2014/main" id="{494B5E1E-5BA1-4B07-BABA-948CF74B6AE4}"/>
+                <a16:creationId xmlns:a16="http://schemas.microsoft.com/office/drawing/2014/main" id="{A9E051CD-1264-4785-8130-2234AD31A177}"/>
               </a:ext>
             </a:extLst>
           </p:cNvPr>
@@ -1487,7 +1487,7 @@
           <p:cNvPr id="2" name="Subtitle">
             <a:extLst xmlns:a="http://schemas.openxmlformats.org/drawingml/2006/main">
               <a:ext uri="{FF2B5EF4-FFF2-40B4-BE49-F238E27FC236}">
-                <a16:creationId xmlns:a16="http://schemas.microsoft.com/office/drawing/2014/main" id="{20ACCAEF-2ABB-45CE-8BC2-EB806DD97E4E}"/>
+                <a16:creationId xmlns:a16="http://schemas.microsoft.com/office/drawing/2014/main" id="{1D3C0FE9-9B2C-442B-B11A-0A71A3942AA1}"/>
               </a:ext>
             </a:extLst>
           </p:cNvPr>
@@ -1661,7 +1661,7 @@
           <p:cNvPr id="2" name="Section title">
             <a:extLst xmlns:a="http://schemas.openxmlformats.org/drawingml/2006/main">
               <a:ext uri="{FF2B5EF4-FFF2-40B4-BE49-F238E27FC236}">
-                <a16:creationId xmlns:a16="http://schemas.microsoft.com/office/drawing/2014/main" id="{1BB0B90D-BD20-42AE-9B14-56024D1770A3}"/>
+                <a16:creationId xmlns:a16="http://schemas.microsoft.com/office/drawing/2014/main" id="{0ACB14D7-6C0C-4A9A-8B02-BADB71844217}"/>
               </a:ext>
             </a:extLst>
           </p:cNvPr>
@@ -1835,7 +1835,7 @@
           <p:cNvPr id="3" name="Title">
             <a:extLst xmlns:a="http://schemas.openxmlformats.org/drawingml/2006/main">
               <a:ext uri="{FF2B5EF4-FFF2-40B4-BE49-F238E27FC236}">
-                <a16:creationId xmlns:a16="http://schemas.microsoft.com/office/drawing/2014/main" id="{89442140-6247-422C-9D3A-30066F4CD57F}"/>
+                <a16:creationId xmlns:a16="http://schemas.microsoft.com/office/drawing/2014/main" id="{F2C1D3D9-D315-48DC-B1B8-DD0E5D5A222E}"/>
               </a:ext>
             </a:extLst>
           </p:cNvPr>
@@ -1992,7 +1992,7 @@
           <p:cNvPr id="2" name="Body">
             <a:extLst xmlns:a="http://schemas.openxmlformats.org/drawingml/2006/main">
               <a:ext uri="{FF2B5EF4-FFF2-40B4-BE49-F238E27FC236}">
-                <a16:creationId xmlns:a16="http://schemas.microsoft.com/office/drawing/2014/main" id="{B10D32CA-3C57-4DB2-9FDF-D355104E53E2}"/>
+                <a16:creationId xmlns:a16="http://schemas.microsoft.com/office/drawing/2014/main" id="{6DFA82EF-BCF7-46C1-B061-F194AC56A196}"/>
               </a:ext>
             </a:extLst>
           </p:cNvPr>
@@ -2166,7 +2166,7 @@
           <p:cNvPr id="4" name="Title">
             <a:extLst xmlns:a="http://schemas.openxmlformats.org/drawingml/2006/main">
               <a:ext uri="{FF2B5EF4-FFF2-40B4-BE49-F238E27FC236}">
-                <a16:creationId xmlns:a16="http://schemas.microsoft.com/office/drawing/2014/main" id="{21AE20BB-FDDB-495C-B249-603DBED52FE0}"/>
+                <a16:creationId xmlns:a16="http://schemas.microsoft.com/office/drawing/2014/main" id="{5AADA053-5BD3-4291-800B-056CFFC6C973}"/>
               </a:ext>
             </a:extLst>
           </p:cNvPr>
@@ -2323,7 +2323,7 @@
           <p:cNvPr id="2" name="Left column">
             <a:extLst xmlns:a="http://schemas.openxmlformats.org/drawingml/2006/main">
               <a:ext uri="{FF2B5EF4-FFF2-40B4-BE49-F238E27FC236}">
-                <a16:creationId xmlns:a16="http://schemas.microsoft.com/office/drawing/2014/main" id="{F80CD30C-241C-494A-8DE6-7959B4D8EACE}"/>
+                <a16:creationId xmlns:a16="http://schemas.microsoft.com/office/drawing/2014/main" id="{756AFE28-DA8C-4F6A-B2B3-DCAD2004489E}"/>
               </a:ext>
             </a:extLst>
           </p:cNvPr>
@@ -2480,7 +2480,7 @@
           <p:cNvPr id="3" name="Right column">
             <a:extLst xmlns:a="http://schemas.openxmlformats.org/drawingml/2006/main">
               <a:ext uri="{FF2B5EF4-FFF2-40B4-BE49-F238E27FC236}">
-                <a16:creationId xmlns:a16="http://schemas.microsoft.com/office/drawing/2014/main" id="{4C672CB2-6F11-4107-B550-0E39DF42F4F0}"/>
+                <a16:creationId xmlns:a16="http://schemas.microsoft.com/office/drawing/2014/main" id="{B3D3A46F-0F18-4746-861C-03A08CE2D88B}"/>
               </a:ext>
             </a:extLst>
           </p:cNvPr>
@@ -2654,7 +2654,7 @@
           <p:cNvPr id="3" name="Title">
             <a:extLst xmlns:a="http://schemas.openxmlformats.org/drawingml/2006/main">
               <a:ext uri="{FF2B5EF4-FFF2-40B4-BE49-F238E27FC236}">
-                <a16:creationId xmlns:a16="http://schemas.microsoft.com/office/drawing/2014/main" id="{BD45B4D9-32DA-4832-98BE-4D064459C263}"/>
+                <a16:creationId xmlns:a16="http://schemas.microsoft.com/office/drawing/2014/main" id="{16951F33-4E8B-42DA-99FA-E8CFD6409DD3}"/>
               </a:ext>
             </a:extLst>
           </p:cNvPr>
@@ -2811,7 +2811,7 @@
           <p:cNvPr id="2" name="Left column">
             <a:extLst xmlns:a="http://schemas.openxmlformats.org/drawingml/2006/main">
               <a:ext uri="{FF2B5EF4-FFF2-40B4-BE49-F238E27FC236}">
-                <a16:creationId xmlns:a16="http://schemas.microsoft.com/office/drawing/2014/main" id="{1262E8E3-AD76-4387-B2E3-2EC8E72C6803}"/>
+                <a16:creationId xmlns:a16="http://schemas.microsoft.com/office/drawing/2014/main" id="{EE83A8C7-BC52-4E29-8A6B-500A5E89AB26}"/>
               </a:ext>
             </a:extLst>
           </p:cNvPr>
@@ -3006,12 +3006,12 @@
   </p:cSld>
   <p:clrMap bg1="lt1" tx1="dk1" bg2="lt2" tx2="dk2" accent1="accent1" accent2="accent2" accent3="accent3" accent4="accent4" accent5="accent5" accent6="accent6" hlink="hlink" folHlink="folHlink"/>
   <p:sldLayoutIdLst>
-    <p:sldLayoutId xmlns:r="http://schemas.openxmlformats.org/officeDocument/2006/relationships" id="2147483649" r:id="Rf611798b37fc4679"/>
-    <p:sldLayoutId xmlns:r="http://schemas.openxmlformats.org/officeDocument/2006/relationships" id="2147483650" r:id="R912b912e0a274d67"/>
-    <p:sldLayoutId xmlns:r="http://schemas.openxmlformats.org/officeDocument/2006/relationships" id="2147483651" r:id="R04829bc541064050"/>
-    <p:sldLayoutId xmlns:r="http://schemas.openxmlformats.org/officeDocument/2006/relationships" id="2147483652" r:id="R531b05f9625b4350"/>
-    <p:sldLayoutId xmlns:r="http://schemas.openxmlformats.org/officeDocument/2006/relationships" id="2147483653" r:id="Rac1ea43dc0514c0c"/>
-    <p:sldLayoutId xmlns:r="http://schemas.openxmlformats.org/officeDocument/2006/relationships" id="2147483654" r:id="R1080504228144336"/>
+    <p:sldLayoutId xmlns:r="http://schemas.openxmlformats.org/officeDocument/2006/relationships" id="2147483649" r:id="R0e998eef04204ed7"/>
+    <p:sldLayoutId xmlns:r="http://schemas.openxmlformats.org/officeDocument/2006/relationships" id="2147483650" r:id="Ra954d69d2b324f39"/>
+    <p:sldLayoutId xmlns:r="http://schemas.openxmlformats.org/officeDocument/2006/relationships" id="2147483651" r:id="R281d56d581514f40"/>
+    <p:sldLayoutId xmlns:r="http://schemas.openxmlformats.org/officeDocument/2006/relationships" id="2147483652" r:id="R25ae80f49db6490a"/>
+    <p:sldLayoutId xmlns:r="http://schemas.openxmlformats.org/officeDocument/2006/relationships" id="2147483653" r:id="R040959e198554655"/>
+    <p:sldLayoutId xmlns:r="http://schemas.openxmlformats.org/officeDocument/2006/relationships" id="2147483654" r:id="R58996c5be5b246d5"/>
   </p:sldLayoutIdLst>
   <p:txStyles>
     <p:titleStyle>
@@ -3562,7 +3562,7 @@
           <p:cNvPr id="7" name="">
             <a:extLst xmlns:a="http://schemas.openxmlformats.org/drawingml/2006/main">
               <a:ext uri="{FF2B5EF4-FFF2-40B4-BE49-F238E27FC236}">
-                <a16:creationId xmlns:a16="http://schemas.microsoft.com/office/drawing/2014/main" id="{7218B64B-EFDA-4C0D-B54F-326DF74C0F89}"/>
+                <a16:creationId xmlns:a16="http://schemas.microsoft.com/office/drawing/2014/main" id="{BFC8331E-44C8-4015-A9FE-674200E9657A}"/>
               </a:ext>
             </a:extLst>
           </p:cNvPr>
@@ -3628,7 +3628,7 @@
           <p:cNvPr id="2" name="">
             <a:extLst xmlns:a="http://schemas.openxmlformats.org/drawingml/2006/main">
               <a:ext uri="{FF2B5EF4-FFF2-40B4-BE49-F238E27FC236}">
-                <a16:creationId xmlns:a16="http://schemas.microsoft.com/office/drawing/2014/main" id="{34DDA646-BB67-471F-842A-5FA40F97720D}"/>
+                <a16:creationId xmlns:a16="http://schemas.microsoft.com/office/drawing/2014/main" id="{A9310D88-9711-4452-A704-4E96D61DFE61}"/>
               </a:ext>
             </a:extLst>
           </p:cNvPr>
@@ -3694,7 +3694,7 @@
           <p:cNvPr id="3" name="">
             <a:extLst xmlns:a="http://schemas.openxmlformats.org/drawingml/2006/main">
               <a:ext uri="{FF2B5EF4-FFF2-40B4-BE49-F238E27FC236}">
-                <a16:creationId xmlns:a16="http://schemas.microsoft.com/office/drawing/2014/main" id="{D3251471-AB82-414C-8289-2567FAC492A7}"/>
+                <a16:creationId xmlns:a16="http://schemas.microsoft.com/office/drawing/2014/main" id="{AEECE5BD-603C-4BD0-A6F8-91357C43646C}"/>
               </a:ext>
             </a:extLst>
           </p:cNvPr>
@@ -3760,7 +3760,7 @@
           <p:cNvPr id="4" name="">
             <a:extLst xmlns:a="http://schemas.openxmlformats.org/drawingml/2006/main">
               <a:ext uri="{FF2B5EF4-FFF2-40B4-BE49-F238E27FC236}">
-                <a16:creationId xmlns:a16="http://schemas.microsoft.com/office/drawing/2014/main" id="{04A3BD8D-B25E-42DA-AFEE-19E3868F9AB3}"/>
+                <a16:creationId xmlns:a16="http://schemas.microsoft.com/office/drawing/2014/main" id="{CBF60EEF-A49F-4390-8B5F-C6DE8A0B5B25}"/>
               </a:ext>
             </a:extLst>
           </p:cNvPr>
@@ -3826,7 +3826,7 @@
           <p:cNvPr id="5" name="">
             <a:extLst xmlns:a="http://schemas.openxmlformats.org/drawingml/2006/main">
               <a:ext uri="{FF2B5EF4-FFF2-40B4-BE49-F238E27FC236}">
-                <a16:creationId xmlns:a16="http://schemas.microsoft.com/office/drawing/2014/main" id="{F04E3191-B2C0-4071-AA81-C02326137757}"/>
+                <a16:creationId xmlns:a16="http://schemas.microsoft.com/office/drawing/2014/main" id="{0F5A553D-A0AB-47AC-B074-7AB102D8EC33}"/>
               </a:ext>
             </a:extLst>
           </p:cNvPr>
@@ -3892,7 +3892,7 @@
           <p:cNvPr id="6" name="">
             <a:extLst xmlns:a="http://schemas.openxmlformats.org/drawingml/2006/main">
               <a:ext uri="{FF2B5EF4-FFF2-40B4-BE49-F238E27FC236}">
-                <a16:creationId xmlns:a16="http://schemas.microsoft.com/office/drawing/2014/main" id="{17BA8A40-5DEF-4593-98BE-A609E1F10B47}"/>
+                <a16:creationId xmlns:a16="http://schemas.microsoft.com/office/drawing/2014/main" id="{31068DF0-1C48-4C47-9463-0F5DC40DC7ED}"/>
               </a:ext>
             </a:extLst>
           </p:cNvPr>
@@ -3956,7 +3956,7 @@
     </p:spTree>
     <p:extLst>
       <p:ext uri="{BB962C8B-B14F-4D97-AF65-F5344CB8AC3E}">
-        <p14:creationId xmlns:p14="http://schemas.microsoft.com/office/powerpoint/2010/main" val="523819938"/>
+        <p14:creationId xmlns:p14="http://schemas.microsoft.com/office/powerpoint/2010/main" val="1318860648"/>
       </p:ext>
     </p:extLst>
   </p:cSld>
@@ -3987,7 +3987,7 @@
           <p:cNvPr id="6" name="">
             <a:extLst xmlns:a="http://schemas.openxmlformats.org/drawingml/2006/main">
               <a:ext uri="{FF2B5EF4-FFF2-40B4-BE49-F238E27FC236}">
-                <a16:creationId xmlns:a16="http://schemas.microsoft.com/office/drawing/2014/main" id="{EB5EA31F-1DE1-4FBD-AB63-8CC03FEB212E}"/>
+                <a16:creationId xmlns:a16="http://schemas.microsoft.com/office/drawing/2014/main" id="{E10230D3-1E36-4023-833D-06BEA26B77F2}"/>
               </a:ext>
             </a:extLst>
           </p:cNvPr>
@@ -4053,7 +4053,7 @@
           <p:cNvPr id="2" name="">
             <a:extLst xmlns:a="http://schemas.openxmlformats.org/drawingml/2006/main">
               <a:ext uri="{FF2B5EF4-FFF2-40B4-BE49-F238E27FC236}">
-                <a16:creationId xmlns:a16="http://schemas.microsoft.com/office/drawing/2014/main" id="{D7A409F3-07BB-4587-816F-B2CB237BFE68}"/>
+                <a16:creationId xmlns:a16="http://schemas.microsoft.com/office/drawing/2014/main" id="{BB322A4B-E047-4263-8108-1A55399AC2AE}"/>
               </a:ext>
             </a:extLst>
           </p:cNvPr>
@@ -4109,7 +4109,7 @@
                 <a:ea typeface="Arial"/>
                 <a:cs typeface="Arial"/>
               </a:rPr>
-              <a:t>Larger DCLP3 numerical study</a:t>
+              <a:t>Numerical forecast results</a:t>
             </a:r>
           </a:p>
         </p:txBody>
@@ -4119,7 +4119,7 @@
           <p:cNvPr id="3" name="">
             <a:extLst xmlns:a="http://schemas.openxmlformats.org/drawingml/2006/main">
               <a:ext uri="{FF2B5EF4-FFF2-40B4-BE49-F238E27FC236}">
-                <a16:creationId xmlns:a16="http://schemas.microsoft.com/office/drawing/2014/main" id="{44A7264E-BE37-40D2-9C8A-367776CEFB32}"/>
+                <a16:creationId xmlns:a16="http://schemas.microsoft.com/office/drawing/2014/main" id="{FFC63CCA-401E-43EC-B006-06744541BB84}"/>
               </a:ext>
             </a:extLst>
           </p:cNvPr>
@@ -4128,7 +4128,7 @@
         </p:nvGraphicFramePr>
         <p:xfrm>
           <a:off xmlns:a="http://schemas.openxmlformats.org/drawingml/2006/main" x="609600" y="1952625"/>
-          <a:ext xmlns:a="http://schemas.openxmlformats.org/drawingml/2006/main" cx="10972800" cy="1800225"/>
+          <a:ext xmlns:a="http://schemas.openxmlformats.org/drawingml/2006/main" cx="10972800" cy="2400300"/>
         </p:xfrm>
         <a:graphic xmlns:a="http://schemas.openxmlformats.org/drawingml/2006/main">
           <a:graphicData uri="http://schemas.openxmlformats.org/drawingml/2006/table">
@@ -4154,7 +4154,7 @@
                           <a:ea typeface="Arial"/>
                           <a:cs typeface="Arial"/>
                         </a:rPr>
-                        <a:t>Participant MAE (mg/dL)</a:t>
+                        <a:t>Cohort / horizon</a:t>
                       </a:r>
                     </a:p>
                   </a:txBody>
@@ -4178,7 +4178,7 @@
                           <a:ea typeface="Arial"/>
                           <a:cs typeface="Arial"/>
                         </a:rPr>
-                        <a:t>30 minutes</a:t>
+                        <a:t>Ridge MAE</a:t>
                       </a:r>
                     </a:p>
                   </a:txBody>
@@ -4202,7 +4202,7 @@
                           <a:ea typeface="Arial"/>
                           <a:cs typeface="Arial"/>
                         </a:rPr>
-                        <a:t>60 minutes</a:t>
+                        <a:t>Persistence MAE</a:t>
                       </a:r>
                     </a:p>
                   </a:txBody>
@@ -4228,7 +4228,7 @@
                           <a:ea typeface="Arial"/>
                           <a:cs typeface="Arial"/>
                         </a:rPr>
-                        <a:t>Persistence</a:t>
+                        <a:t>CGMacros / 60 min</a:t>
                       </a:r>
                     </a:p>
                   </a:txBody>
@@ -4252,7 +4252,7 @@
                           <a:ea typeface="Arial"/>
                           <a:cs typeface="Arial"/>
                         </a:rPr>
-                        <a:t>20.92</a:t>
+                        <a:t>19.00</a:t>
                       </a:r>
                     </a:p>
                   </a:txBody>
@@ -4276,7 +4276,7 @@
                           <a:ea typeface="Arial"/>
                           <a:cs typeface="Arial"/>
                         </a:rPr>
-                        <a:t>32.32</a:t>
+                        <a:t>19.99</a:t>
                       </a:r>
                     </a:p>
                   </a:txBody>
@@ -4302,7 +4302,7 @@
                           <a:ea typeface="Arial"/>
                           <a:cs typeface="Arial"/>
                         </a:rPr>
-                        <a:t>CGM-only XGBoost</a:t>
+                        <a:t>RBG / 30 min</a:t>
                       </a:r>
                     </a:p>
                   </a:txBody>
@@ -4326,7 +4326,7 @@
                           <a:ea typeface="Arial"/>
                           <a:cs typeface="Arial"/>
                         </a:rPr>
-                        <a:t>17.53</a:t>
+                        <a:t>17.59</a:t>
                       </a:r>
                     </a:p>
                   </a:txBody>
@@ -4350,7 +4350,81 @@
                           <a:ea typeface="Arial"/>
                           <a:cs typeface="Arial"/>
                         </a:rPr>
-                        <a:t>27.47</a:t>
+                        <a:t>20.71</a:t>
+                      </a:r>
+                    </a:p>
+                  </a:txBody>
+                  <a:tcPr marL="91440" marR="91440" marT="45720" marB="45720">
+                    <a:solidFill>
+                      <a:srgbClr val="FFFFFF"/>
+                    </a:solidFill>
+                  </a:tcPr>
+                </a:tc>
+              </a:tr>
+              <a:tr h="600075">
+                <a:tc>
+                  <a:txBody>
+                    <a:bodyPr/>
+                    <a:lstStyle/>
+                    <a:p>
+                      <a:r>
+                        <a:rPr sz="1950" b="0">
+                          <a:solidFill>
+                            <a:srgbClr val="183344"/>
+                          </a:solidFill>
+                          <a:latin typeface="Arial"/>
+                          <a:ea typeface="Arial"/>
+                          <a:cs typeface="Arial"/>
+                        </a:rPr>
+                        <a:t>RBG / 60 min</a:t>
+                      </a:r>
+                    </a:p>
+                  </a:txBody>
+                  <a:tcPr marL="91440" marR="91440" marT="45720" marB="45720">
+                    <a:solidFill>
+                      <a:srgbClr val="FFFFFF"/>
+                    </a:solidFill>
+                  </a:tcPr>
+                </a:tc>
+                <a:tc>
+                  <a:txBody>
+                    <a:bodyPr/>
+                    <a:lstStyle/>
+                    <a:p>
+                      <a:r>
+                        <a:rPr sz="1950" b="0">
+                          <a:solidFill>
+                            <a:srgbClr val="183344"/>
+                          </a:solidFill>
+                          <a:latin typeface="Arial"/>
+                          <a:ea typeface="Arial"/>
+                          <a:cs typeface="Arial"/>
+                        </a:rPr>
+                        <a:t>28.89</a:t>
+                      </a:r>
+                    </a:p>
+                  </a:txBody>
+                  <a:tcPr marL="91440" marR="91440" marT="45720" marB="45720">
+                    <a:solidFill>
+                      <a:srgbClr val="FFFFFF"/>
+                    </a:solidFill>
+                  </a:tcPr>
+                </a:tc>
+                <a:tc>
+                  <a:txBody>
+                    <a:bodyPr/>
+                    <a:lstStyle/>
+                    <a:p>
+                      <a:r>
+                        <a:rPr sz="1950" b="0">
+                          <a:solidFill>
+                            <a:srgbClr val="183344"/>
+                          </a:solidFill>
+                          <a:latin typeface="Arial"/>
+                          <a:ea typeface="Arial"/>
+                          <a:cs typeface="Arial"/>
+                        </a:rPr>
+                        <a:t>32.53</a:t>
                       </a:r>
                     </a:p>
                   </a:txBody>
@@ -4370,7 +4444,7 @@
           <p:cNvPr id="4" name="">
             <a:extLst xmlns:a="http://schemas.openxmlformats.org/drawingml/2006/main">
               <a:ext uri="{FF2B5EF4-FFF2-40B4-BE49-F238E27FC236}">
-                <a16:creationId xmlns:a16="http://schemas.microsoft.com/office/drawing/2014/main" id="{6533C65D-6D82-4E57-BF36-6D60870E9645}"/>
+                <a16:creationId xmlns:a16="http://schemas.microsoft.com/office/drawing/2014/main" id="{EA496634-3151-4931-832B-09AD1B8213E7}"/>
               </a:ext>
             </a:extLst>
           </p:cNvPr>
@@ -4381,7 +4455,7 @@
         </p:nvSpPr>
         <p:spPr>
           <a:xfrm xmlns:a="http://schemas.openxmlformats.org/drawingml/2006/main">
-            <a:off x="609600" y="3895725"/>
+            <a:off x="609600" y="4495800"/>
             <a:ext cx="10972800" cy="1066800"/>
           </a:xfrm>
           <a:prstGeom xmlns:a="http://schemas.openxmlformats.org/drawingml/2006/main" prst="rect">
@@ -4426,7 +4500,7 @@
                 <a:ea typeface="Arial"/>
                 <a:cs typeface="Arial"/>
               </a:rPr>
-              <a:t>134 development patients, 4 patient-disjoint folds; 34 reserved unscored. Separate cohort; approximately 35/65-minute lookahead from the latest reading.</a:t>
+              <a:t>Units: mg/dL. Separate development cohorts and timing protocols. RBG profile-fused values match the original CGM-only benchmark after rounding.</a:t>
             </a:r>
           </a:p>
         </p:txBody>
@@ -4436,7 +4510,7 @@
           <p:cNvPr id="5" name="">
             <a:extLst xmlns:a="http://schemas.openxmlformats.org/drawingml/2006/main">
               <a:ext uri="{FF2B5EF4-FFF2-40B4-BE49-F238E27FC236}">
-                <a16:creationId xmlns:a16="http://schemas.microsoft.com/office/drawing/2014/main" id="{62C3E71F-F00D-4B70-823A-AC30B5A95943}"/>
+                <a16:creationId xmlns:a16="http://schemas.microsoft.com/office/drawing/2014/main" id="{4A06210B-D445-4433-9CDD-177F8DD0D72A}"/>
               </a:ext>
             </a:extLst>
           </p:cNvPr>
@@ -4500,7 +4574,7 @@
     </p:spTree>
     <p:extLst>
       <p:ext uri="{BB962C8B-B14F-4D97-AF65-F5344CB8AC3E}">
-        <p14:creationId xmlns:p14="http://schemas.microsoft.com/office/powerpoint/2010/main" val="854880150"/>
+        <p14:creationId xmlns:p14="http://schemas.microsoft.com/office/powerpoint/2010/main" val="591356051"/>
       </p:ext>
     </p:extLst>
   </p:cSld>
@@ -4531,7 +4605,7 @@
           <p:cNvPr id="8" name="">
             <a:extLst xmlns:a="http://schemas.openxmlformats.org/drawingml/2006/main">
               <a:ext uri="{FF2B5EF4-FFF2-40B4-BE49-F238E27FC236}">
-                <a16:creationId xmlns:a16="http://schemas.microsoft.com/office/drawing/2014/main" id="{EDC48FE1-5638-40FD-93A5-8DFDDB72C7E3}"/>
+                <a16:creationId xmlns:a16="http://schemas.microsoft.com/office/drawing/2014/main" id="{0458C7CF-5A3F-446E-8CE0-574888027D5F}"/>
               </a:ext>
             </a:extLst>
           </p:cNvPr>
@@ -4597,7 +4671,7 @@
           <p:cNvPr id="2" name="">
             <a:extLst xmlns:a="http://schemas.openxmlformats.org/drawingml/2006/main">
               <a:ext uri="{FF2B5EF4-FFF2-40B4-BE49-F238E27FC236}">
-                <a16:creationId xmlns:a16="http://schemas.microsoft.com/office/drawing/2014/main" id="{14C0C9BC-0259-4116-A81B-1B9020956C64}"/>
+                <a16:creationId xmlns:a16="http://schemas.microsoft.com/office/drawing/2014/main" id="{87AA37A7-2B73-4209-8797-7EAEEFE98FC5}"/>
               </a:ext>
             </a:extLst>
           </p:cNvPr>
@@ -4653,7 +4727,7 @@
                 <a:ea typeface="Arial"/>
                 <a:cs typeface="Arial"/>
               </a:rPr>
-              <a:t>Limits that affect the conclusion</a:t>
+              <a:t>Current model limitations</a:t>
             </a:r>
           </a:p>
         </p:txBody>
@@ -4663,7 +4737,7 @@
           <p:cNvPr id="3" name="">
             <a:extLst xmlns:a="http://schemas.openxmlformats.org/drawingml/2006/main">
               <a:ext uri="{FF2B5EF4-FFF2-40B4-BE49-F238E27FC236}">
-                <a16:creationId xmlns:a16="http://schemas.microsoft.com/office/drawing/2014/main" id="{4243FAF2-99B0-4CFD-BD6A-485665DB14D5}"/>
+                <a16:creationId xmlns:a16="http://schemas.microsoft.com/office/drawing/2014/main" id="{177FEC93-A862-4612-AF32-551A8C4C1254}"/>
               </a:ext>
             </a:extLst>
           </p:cNvPr>
@@ -4719,7 +4793,7 @@
                 <a:ea typeface="Arial"/>
                 <a:cs typeface="Arial"/>
               </a:rPr>
-              <a:t>Only 36.6% of evaluable episodes received at least ten minutes warning in the v2 development backtest.</a:t>
+              <a:t>Only 36.6% of evaluable high episodes received at least ten minutes warning. Cutoff-setting folds did not consistently pass.</a:t>
             </a:r>
           </a:p>
         </p:txBody>
@@ -4729,7 +4803,7 @@
           <p:cNvPr id="4" name="">
             <a:extLst xmlns:a="http://schemas.openxmlformats.org/drawingml/2006/main">
               <a:ext uri="{FF2B5EF4-FFF2-40B4-BE49-F238E27FC236}">
-                <a16:creationId xmlns:a16="http://schemas.microsoft.com/office/drawing/2014/main" id="{5B6E9E87-30BA-4C3E-A375-79C52A4A454E}"/>
+                <a16:creationId xmlns:a16="http://schemas.microsoft.com/office/drawing/2014/main" id="{B29AA578-36AC-40B4-A1CB-4733EDE9A71E}"/>
               </a:ext>
             </a:extLst>
           </p:cNvPr>
@@ -4785,7 +4859,7 @@
                 <a:ea typeface="Arial"/>
                 <a:cs typeface="Arial"/>
               </a:rPr>
-              <a:t>Later onset v3 recall fell to 51.5%; it was rejected as an overall improvement.</a:t>
+              <a:t>Low-glucose numerical errors remain a weakness. Overall MAE is not a clinical safety guarantee.</a:t>
             </a:r>
           </a:p>
         </p:txBody>
@@ -4795,7 +4869,7 @@
           <p:cNvPr id="5" name="">
             <a:extLst xmlns:a="http://schemas.openxmlformats.org/drawingml/2006/main">
               <a:ext uri="{FF2B5EF4-FFF2-40B4-BE49-F238E27FC236}">
-                <a16:creationId xmlns:a16="http://schemas.microsoft.com/office/drawing/2014/main" id="{96B83373-6255-4599-B97E-B93980A17CE5}"/>
+                <a16:creationId xmlns:a16="http://schemas.microsoft.com/office/drawing/2014/main" id="{C8CB7C8F-57F4-4E79-834F-35806DF416F6}"/>
               </a:ext>
             </a:extLst>
           </p:cNvPr>
@@ -4851,7 +4925,7 @@
                 <a:ea typeface="Arial"/>
                 <a:cs typeface="Arial"/>
               </a:rPr>
-              <a:t>DCLP3 low-target 60-minute MAE: 54.31 versus persistence 50.04. Clinical fields added no convincing overall gain.</a:t>
+              <a:t>CGMacros samples are reconstructed; historical profile availability is assumed. A useful clinical-fusion advantage is not established.</a:t>
             </a:r>
           </a:p>
         </p:txBody>
@@ -4861,7 +4935,7 @@
           <p:cNvPr id="6" name="">
             <a:extLst xmlns:a="http://schemas.openxmlformats.org/drawingml/2006/main">
               <a:ext uri="{FF2B5EF4-FFF2-40B4-BE49-F238E27FC236}">
-                <a16:creationId xmlns:a16="http://schemas.microsoft.com/office/drawing/2014/main" id="{40D44153-BE3C-44E3-B829-6C675D081472}"/>
+                <a16:creationId xmlns:a16="http://schemas.microsoft.com/office/drawing/2014/main" id="{54767F88-F15C-4F92-AF7F-6A7E781477EE}"/>
               </a:ext>
             </a:extLst>
           </p:cNvPr>
@@ -4917,7 +4991,7 @@
                 <a:ea typeface="Arial"/>
                 <a:cs typeface="Arial"/>
               </a:rPr>
-              <a:t>No clinical validation. Risk percentages, operational alerts and treatment advice remain disabled.</a:t>
+              <a:t>No clinical validation or reserved-test performance. Risk percentages, operational alerts and treatment advice remain disabled.</a:t>
             </a:r>
           </a:p>
         </p:txBody>
@@ -4927,7 +5001,7 @@
           <p:cNvPr id="7" name="">
             <a:extLst xmlns:a="http://schemas.openxmlformats.org/drawingml/2006/main">
               <a:ext uri="{FF2B5EF4-FFF2-40B4-BE49-F238E27FC236}">
-                <a16:creationId xmlns:a16="http://schemas.microsoft.com/office/drawing/2014/main" id="{5659F326-4F33-4014-A187-5FDFB31D6C9B}"/>
+                <a16:creationId xmlns:a16="http://schemas.microsoft.com/office/drawing/2014/main" id="{C99A8DDA-4B1C-4436-8EB9-3B4828C1AB46}"/>
               </a:ext>
             </a:extLst>
           </p:cNvPr>
@@ -4991,7 +5065,7 @@
     </p:spTree>
     <p:extLst>
       <p:ext uri="{BB962C8B-B14F-4D97-AF65-F5344CB8AC3E}">
-        <p14:creationId xmlns:p14="http://schemas.microsoft.com/office/powerpoint/2010/main" val="1586797494"/>
+        <p14:creationId xmlns:p14="http://schemas.microsoft.com/office/powerpoint/2010/main" val="310137681"/>
       </p:ext>
     </p:extLst>
   </p:cSld>
@@ -5022,7 +5096,7 @@
           <p:cNvPr id="8" name="">
             <a:extLst xmlns:a="http://schemas.openxmlformats.org/drawingml/2006/main">
               <a:ext uri="{FF2B5EF4-FFF2-40B4-BE49-F238E27FC236}">
-                <a16:creationId xmlns:a16="http://schemas.microsoft.com/office/drawing/2014/main" id="{98D80C9D-085B-4A0E-84EC-9AC30D3A1D10}"/>
+                <a16:creationId xmlns:a16="http://schemas.microsoft.com/office/drawing/2014/main" id="{8411D363-8A87-43A5-869A-9407F4D24702}"/>
               </a:ext>
             </a:extLst>
           </p:cNvPr>
@@ -5088,7 +5162,7 @@
           <p:cNvPr id="2" name="">
             <a:extLst xmlns:a="http://schemas.openxmlformats.org/drawingml/2006/main">
               <a:ext uri="{FF2B5EF4-FFF2-40B4-BE49-F238E27FC236}">
-                <a16:creationId xmlns:a16="http://schemas.microsoft.com/office/drawing/2014/main" id="{71C85F2D-EB9B-4AE3-BE4C-B93A8DAD9042}"/>
+                <a16:creationId xmlns:a16="http://schemas.microsoft.com/office/drawing/2014/main" id="{4B722B51-719A-4C70-AAC4-BC19A3959CDF}"/>
               </a:ext>
             </a:extLst>
           </p:cNvPr>
@@ -5154,7 +5228,7 @@
           <p:cNvPr id="3" name="">
             <a:extLst xmlns:a="http://schemas.openxmlformats.org/drawingml/2006/main">
               <a:ext uri="{FF2B5EF4-FFF2-40B4-BE49-F238E27FC236}">
-                <a16:creationId xmlns:a16="http://schemas.microsoft.com/office/drawing/2014/main" id="{507C45A7-A069-424E-AC55-072303A1A014}"/>
+                <a16:creationId xmlns:a16="http://schemas.microsoft.com/office/drawing/2014/main" id="{76187F4A-8EC4-47E5-907E-520864E95152}"/>
               </a:ext>
             </a:extLst>
           </p:cNvPr>
@@ -5220,7 +5294,7 @@
           <p:cNvPr id="4" name="">
             <a:extLst xmlns:a="http://schemas.openxmlformats.org/drawingml/2006/main">
               <a:ext uri="{FF2B5EF4-FFF2-40B4-BE49-F238E27FC236}">
-                <a16:creationId xmlns:a16="http://schemas.microsoft.com/office/drawing/2014/main" id="{665CDF86-56A4-454A-A200-3E19FFAF72E5}"/>
+                <a16:creationId xmlns:a16="http://schemas.microsoft.com/office/drawing/2014/main" id="{86E73E9E-F88D-4740-B70E-F04F37315346}"/>
               </a:ext>
             </a:extLst>
           </p:cNvPr>
@@ -5276,7 +5350,7 @@
                 <a:ea typeface="Arial"/>
                 <a:cs typeface="Arial"/>
               </a:rPr>
-              <a:t>Reproducible scripts, frozen configurations and aggregate reports are in the repository; records and model binaries stay local.</a:t>
+              <a:t>The repository contains the active application, model preparation code, essential documentation and current-model checks. Records and model binaries stay local.</a:t>
             </a:r>
           </a:p>
         </p:txBody>
@@ -5286,7 +5360,7 @@
           <p:cNvPr id="5" name="">
             <a:extLst xmlns:a="http://schemas.openxmlformats.org/drawingml/2006/main">
               <a:ext uri="{FF2B5EF4-FFF2-40B4-BE49-F238E27FC236}">
-                <a16:creationId xmlns:a16="http://schemas.microsoft.com/office/drawing/2014/main" id="{217A0D23-D876-4735-BABC-5FB42ADB4EF4}"/>
+                <a16:creationId xmlns:a16="http://schemas.microsoft.com/office/drawing/2014/main" id="{5E6E399E-9B05-4FC8-8DBD-187FE428AD2C}"/>
               </a:ext>
             </a:extLst>
           </p:cNvPr>
@@ -5352,7 +5426,7 @@
           <p:cNvPr id="6" name="">
             <a:extLst xmlns:a="http://schemas.openxmlformats.org/drawingml/2006/main">
               <a:ext uri="{FF2B5EF4-FFF2-40B4-BE49-F238E27FC236}">
-                <a16:creationId xmlns:a16="http://schemas.microsoft.com/office/drawing/2014/main" id="{02F7F7D1-35FF-4C96-9624-0B7EDF74BD71}"/>
+                <a16:creationId xmlns:a16="http://schemas.microsoft.com/office/drawing/2014/main" id="{233AE45E-9E08-472C-BC6A-AE3AF2705272}"/>
               </a:ext>
             </a:extLst>
           </p:cNvPr>
@@ -5418,7 +5492,7 @@
           <p:cNvPr id="7" name="">
             <a:extLst xmlns:a="http://schemas.openxmlformats.org/drawingml/2006/main">
               <a:ext uri="{FF2B5EF4-FFF2-40B4-BE49-F238E27FC236}">
-                <a16:creationId xmlns:a16="http://schemas.microsoft.com/office/drawing/2014/main" id="{D3C10FE1-65E1-4E3D-B10B-B7BBD9FE6B47}"/>
+                <a16:creationId xmlns:a16="http://schemas.microsoft.com/office/drawing/2014/main" id="{07EBB849-C101-4640-8100-760B203AFB49}"/>
               </a:ext>
             </a:extLst>
           </p:cNvPr>
@@ -5482,7 +5556,7 @@
     </p:spTree>
     <p:extLst>
       <p:ext uri="{BB962C8B-B14F-4D97-AF65-F5344CB8AC3E}">
-        <p14:creationId xmlns:p14="http://schemas.microsoft.com/office/powerpoint/2010/main" val="932844727"/>
+        <p14:creationId xmlns:p14="http://schemas.microsoft.com/office/powerpoint/2010/main" val="2011990412"/>
       </p:ext>
     </p:extLst>
   </p:cSld>
@@ -5513,7 +5587,7 @@
           <p:cNvPr id="8" name="">
             <a:extLst xmlns:a="http://schemas.openxmlformats.org/drawingml/2006/main">
               <a:ext uri="{FF2B5EF4-FFF2-40B4-BE49-F238E27FC236}">
-                <a16:creationId xmlns:a16="http://schemas.microsoft.com/office/drawing/2014/main" id="{6363207A-B1C2-479D-8C8B-CAEA6E65E550}"/>
+                <a16:creationId xmlns:a16="http://schemas.microsoft.com/office/drawing/2014/main" id="{6BD22536-57CA-4C3D-9DD5-3BBEF12A999C}"/>
               </a:ext>
             </a:extLst>
           </p:cNvPr>
@@ -5579,7 +5653,7 @@
           <p:cNvPr id="2" name="">
             <a:extLst xmlns:a="http://schemas.openxmlformats.org/drawingml/2006/main">
               <a:ext uri="{FF2B5EF4-FFF2-40B4-BE49-F238E27FC236}">
-                <a16:creationId xmlns:a16="http://schemas.microsoft.com/office/drawing/2014/main" id="{A2F229B6-14B7-452E-9281-2C2B1203AB11}"/>
+                <a16:creationId xmlns:a16="http://schemas.microsoft.com/office/drawing/2014/main" id="{CE64991F-CEC8-4733-A9A2-0F9A683C6931}"/>
               </a:ext>
             </a:extLst>
           </p:cNvPr>
@@ -5645,7 +5719,7 @@
           <p:cNvPr id="3" name="">
             <a:extLst xmlns:a="http://schemas.openxmlformats.org/drawingml/2006/main">
               <a:ext uri="{FF2B5EF4-FFF2-40B4-BE49-F238E27FC236}">
-                <a16:creationId xmlns:a16="http://schemas.microsoft.com/office/drawing/2014/main" id="{C20026D0-E4D7-4626-AA2A-0D958181D404}"/>
+                <a16:creationId xmlns:a16="http://schemas.microsoft.com/office/drawing/2014/main" id="{5388C217-9876-4FAB-8CE9-32A6040CFCC8}"/>
               </a:ext>
             </a:extLst>
           </p:cNvPr>
@@ -5711,7 +5785,7 @@
           <p:cNvPr id="4" name="">
             <a:extLst xmlns:a="http://schemas.openxmlformats.org/drawingml/2006/main">
               <a:ext uri="{FF2B5EF4-FFF2-40B4-BE49-F238E27FC236}">
-                <a16:creationId xmlns:a16="http://schemas.microsoft.com/office/drawing/2014/main" id="{32CD6AD2-892A-45EC-BB96-7B8C7DD74145}"/>
+                <a16:creationId xmlns:a16="http://schemas.microsoft.com/office/drawing/2014/main" id="{BA60C4FC-938B-46BD-A3A2-93C4D5B94431}"/>
               </a:ext>
             </a:extLst>
           </p:cNvPr>
@@ -5777,7 +5851,7 @@
           <p:cNvPr id="5" name="">
             <a:extLst xmlns:a="http://schemas.openxmlformats.org/drawingml/2006/main">
               <a:ext uri="{FF2B5EF4-FFF2-40B4-BE49-F238E27FC236}">
-                <a16:creationId xmlns:a16="http://schemas.microsoft.com/office/drawing/2014/main" id="{6D5A8133-F35A-40B9-9CA8-4F6E0E2C83A3}"/>
+                <a16:creationId xmlns:a16="http://schemas.microsoft.com/office/drawing/2014/main" id="{E48E5B19-1D23-4548-9490-23D0BE166B2E}"/>
               </a:ext>
             </a:extLst>
           </p:cNvPr>
@@ -5843,7 +5917,7 @@
           <p:cNvPr id="6" name="">
             <a:extLst xmlns:a="http://schemas.openxmlformats.org/drawingml/2006/main">
               <a:ext uri="{FF2B5EF4-FFF2-40B4-BE49-F238E27FC236}">
-                <a16:creationId xmlns:a16="http://schemas.microsoft.com/office/drawing/2014/main" id="{B0A3F709-3117-44C3-AA1B-EF759ED73E81}"/>
+                <a16:creationId xmlns:a16="http://schemas.microsoft.com/office/drawing/2014/main" id="{F0C3E86A-4ADF-49D6-BC11-FB1A5A8BF8F5}"/>
               </a:ext>
             </a:extLst>
           </p:cNvPr>
@@ -5909,7 +5983,7 @@
           <p:cNvPr id="7" name="">
             <a:extLst xmlns:a="http://schemas.openxmlformats.org/drawingml/2006/main">
               <a:ext uri="{FF2B5EF4-FFF2-40B4-BE49-F238E27FC236}">
-                <a16:creationId xmlns:a16="http://schemas.microsoft.com/office/drawing/2014/main" id="{9EBABF83-6675-48B2-BEC5-40115986EFFB}"/>
+                <a16:creationId xmlns:a16="http://schemas.microsoft.com/office/drawing/2014/main" id="{58143DB8-4735-4ED3-AE12-A22561D5C833}"/>
               </a:ext>
             </a:extLst>
           </p:cNvPr>
@@ -5973,7 +6047,7 @@
     </p:spTree>
     <p:extLst>
       <p:ext uri="{BB962C8B-B14F-4D97-AF65-F5344CB8AC3E}">
-        <p14:creationId xmlns:p14="http://schemas.microsoft.com/office/powerpoint/2010/main" val="967250737"/>
+        <p14:creationId xmlns:p14="http://schemas.microsoft.com/office/powerpoint/2010/main" val="1620938470"/>
       </p:ext>
     </p:extLst>
   </p:cSld>
@@ -6004,7 +6078,7 @@
           <p:cNvPr id="7" name="">
             <a:extLst xmlns:a="http://schemas.openxmlformats.org/drawingml/2006/main">
               <a:ext uri="{FF2B5EF4-FFF2-40B4-BE49-F238E27FC236}">
-                <a16:creationId xmlns:a16="http://schemas.microsoft.com/office/drawing/2014/main" id="{209F8193-2DFA-4ACA-8700-C06BB84FD914}"/>
+                <a16:creationId xmlns:a16="http://schemas.microsoft.com/office/drawing/2014/main" id="{0DB3DCD3-8014-4C78-94D6-F8F7EC4ACF82}"/>
               </a:ext>
             </a:extLst>
           </p:cNvPr>
@@ -6070,7 +6144,7 @@
           <p:cNvPr id="2" name="">
             <a:extLst xmlns:a="http://schemas.openxmlformats.org/drawingml/2006/main">
               <a:ext uri="{FF2B5EF4-FFF2-40B4-BE49-F238E27FC236}">
-                <a16:creationId xmlns:a16="http://schemas.microsoft.com/office/drawing/2014/main" id="{842E851D-766E-4CE9-97ED-9BE15045B573}"/>
+                <a16:creationId xmlns:a16="http://schemas.microsoft.com/office/drawing/2014/main" id="{3016252E-DE79-41CC-B06D-7F6579DF26BF}"/>
               </a:ext>
             </a:extLst>
           </p:cNvPr>
@@ -6136,7 +6210,7 @@
           <p:cNvPr id="3" name="">
             <a:extLst xmlns:a="http://schemas.openxmlformats.org/drawingml/2006/main">
               <a:ext uri="{FF2B5EF4-FFF2-40B4-BE49-F238E27FC236}">
-                <a16:creationId xmlns:a16="http://schemas.microsoft.com/office/drawing/2014/main" id="{C7F1496B-C7F0-4E39-869C-5CF4913EBC51}"/>
+                <a16:creationId xmlns:a16="http://schemas.microsoft.com/office/drawing/2014/main" id="{5F906778-330D-4E39-A319-66EC9560B76D}"/>
               </a:ext>
             </a:extLst>
           </p:cNvPr>
@@ -6202,7 +6276,7 @@
           <p:cNvPr id="4" name="">
             <a:extLst xmlns:a="http://schemas.openxmlformats.org/drawingml/2006/main">
               <a:ext uri="{FF2B5EF4-FFF2-40B4-BE49-F238E27FC236}">
-                <a16:creationId xmlns:a16="http://schemas.microsoft.com/office/drawing/2014/main" id="{EC0E8393-A033-4CA3-85F9-5AE1F583A1AC}"/>
+                <a16:creationId xmlns:a16="http://schemas.microsoft.com/office/drawing/2014/main" id="{EBDE524E-71C5-4487-9B88-BD66753D8A20}"/>
               </a:ext>
             </a:extLst>
           </p:cNvPr>
@@ -6268,7 +6342,7 @@
           <p:cNvPr id="5" name="">
             <a:extLst xmlns:a="http://schemas.openxmlformats.org/drawingml/2006/main">
               <a:ext uri="{FF2B5EF4-FFF2-40B4-BE49-F238E27FC236}">
-                <a16:creationId xmlns:a16="http://schemas.microsoft.com/office/drawing/2014/main" id="{CD85868D-2F7E-400B-BE03-E898AB530FD0}"/>
+                <a16:creationId xmlns:a16="http://schemas.microsoft.com/office/drawing/2014/main" id="{B54B824F-C947-4B18-8CE2-1AFB8D4EEE31}"/>
               </a:ext>
             </a:extLst>
           </p:cNvPr>
@@ -6334,7 +6408,7 @@
           <p:cNvPr id="6" name="">
             <a:extLst xmlns:a="http://schemas.openxmlformats.org/drawingml/2006/main">
               <a:ext uri="{FF2B5EF4-FFF2-40B4-BE49-F238E27FC236}">
-                <a16:creationId xmlns:a16="http://schemas.microsoft.com/office/drawing/2014/main" id="{45F6AB3C-E864-421C-B1E6-211EAD6B0DDB}"/>
+                <a16:creationId xmlns:a16="http://schemas.microsoft.com/office/drawing/2014/main" id="{53F47AA1-3BFC-4BA8-8AF7-C985A62E0389}"/>
               </a:ext>
             </a:extLst>
           </p:cNvPr>
@@ -6398,7 +6472,7 @@
     </p:spTree>
     <p:extLst>
       <p:ext uri="{BB962C8B-B14F-4D97-AF65-F5344CB8AC3E}">
-        <p14:creationId xmlns:p14="http://schemas.microsoft.com/office/powerpoint/2010/main" val="1532539898"/>
+        <p14:creationId xmlns:p14="http://schemas.microsoft.com/office/powerpoint/2010/main" val="1341831875"/>
       </p:ext>
     </p:extLst>
   </p:cSld>
@@ -6429,7 +6503,7 @@
           <p:cNvPr id="7" name="">
             <a:extLst xmlns:a="http://schemas.openxmlformats.org/drawingml/2006/main">
               <a:ext uri="{FF2B5EF4-FFF2-40B4-BE49-F238E27FC236}">
-                <a16:creationId xmlns:a16="http://schemas.microsoft.com/office/drawing/2014/main" id="{CD0516C2-9521-462E-AC80-9AE9245C2219}"/>
+                <a16:creationId xmlns:a16="http://schemas.microsoft.com/office/drawing/2014/main" id="{4E1DD5B2-D809-415E-92BD-6B5C7484A831}"/>
               </a:ext>
             </a:extLst>
           </p:cNvPr>
@@ -6495,7 +6569,7 @@
           <p:cNvPr id="2" name="">
             <a:extLst xmlns:a="http://schemas.openxmlformats.org/drawingml/2006/main">
               <a:ext uri="{FF2B5EF4-FFF2-40B4-BE49-F238E27FC236}">
-                <a16:creationId xmlns:a16="http://schemas.microsoft.com/office/drawing/2014/main" id="{531FECD5-1C93-4910-BB4F-4500FE804430}"/>
+                <a16:creationId xmlns:a16="http://schemas.microsoft.com/office/drawing/2014/main" id="{C39D5538-B051-4BB9-877A-FBFCDDEBC6C1}"/>
               </a:ext>
             </a:extLst>
           </p:cNvPr>
@@ -6561,7 +6635,7 @@
           <p:cNvPr id="3" name="">
             <a:extLst xmlns:a="http://schemas.openxmlformats.org/drawingml/2006/main">
               <a:ext uri="{FF2B5EF4-FFF2-40B4-BE49-F238E27FC236}">
-                <a16:creationId xmlns:a16="http://schemas.microsoft.com/office/drawing/2014/main" id="{95EE3BC5-D3B8-44E7-A6CE-3628D414B8E7}"/>
+                <a16:creationId xmlns:a16="http://schemas.microsoft.com/office/drawing/2014/main" id="{3532EC60-5D05-4C59-840F-DD9C83E9BBC3}"/>
               </a:ext>
             </a:extLst>
           </p:cNvPr>
@@ -6627,7 +6701,7 @@
           <p:cNvPr id="4" name="">
             <a:extLst xmlns:a="http://schemas.openxmlformats.org/drawingml/2006/main">
               <a:ext uri="{FF2B5EF4-FFF2-40B4-BE49-F238E27FC236}">
-                <a16:creationId xmlns:a16="http://schemas.microsoft.com/office/drawing/2014/main" id="{12B92DEF-4DBE-4614-9E86-B6F378F5EBB7}"/>
+                <a16:creationId xmlns:a16="http://schemas.microsoft.com/office/drawing/2014/main" id="{0FC0B1EB-79F9-4590-9E14-984FF11C7558}"/>
               </a:ext>
             </a:extLst>
           </p:cNvPr>
@@ -6693,7 +6767,7 @@
           <p:cNvPr id="5" name="">
             <a:extLst xmlns:a="http://schemas.openxmlformats.org/drawingml/2006/main">
               <a:ext uri="{FF2B5EF4-FFF2-40B4-BE49-F238E27FC236}">
-                <a16:creationId xmlns:a16="http://schemas.microsoft.com/office/drawing/2014/main" id="{8BDD838A-56E0-4265-9A9E-765EE2BA9E3A}"/>
+                <a16:creationId xmlns:a16="http://schemas.microsoft.com/office/drawing/2014/main" id="{53745B8F-75C3-453E-8C9C-9CCC6741FB40}"/>
               </a:ext>
             </a:extLst>
           </p:cNvPr>
@@ -6759,7 +6833,7 @@
           <p:cNvPr id="6" name="">
             <a:extLst xmlns:a="http://schemas.openxmlformats.org/drawingml/2006/main">
               <a:ext uri="{FF2B5EF4-FFF2-40B4-BE49-F238E27FC236}">
-                <a16:creationId xmlns:a16="http://schemas.microsoft.com/office/drawing/2014/main" id="{95C7A454-5049-41B0-AC58-7A0F6122E400}"/>
+                <a16:creationId xmlns:a16="http://schemas.microsoft.com/office/drawing/2014/main" id="{930193C9-1858-42C1-9A5F-B55207A5915A}"/>
               </a:ext>
             </a:extLst>
           </p:cNvPr>
@@ -6823,7 +6897,7 @@
     </p:spTree>
     <p:extLst>
       <p:ext uri="{BB962C8B-B14F-4D97-AF65-F5344CB8AC3E}">
-        <p14:creationId xmlns:p14="http://schemas.microsoft.com/office/powerpoint/2010/main" val="82420428"/>
+        <p14:creationId xmlns:p14="http://schemas.microsoft.com/office/powerpoint/2010/main" val="2009166000"/>
       </p:ext>
     </p:extLst>
   </p:cSld>
@@ -6854,7 +6928,7 @@
           <p:cNvPr id="7" name="">
             <a:extLst xmlns:a="http://schemas.openxmlformats.org/drawingml/2006/main">
               <a:ext uri="{FF2B5EF4-FFF2-40B4-BE49-F238E27FC236}">
-                <a16:creationId xmlns:a16="http://schemas.microsoft.com/office/drawing/2014/main" id="{E58EC92D-9F45-443A-AE3E-BCB8CCC3FE6C}"/>
+                <a16:creationId xmlns:a16="http://schemas.microsoft.com/office/drawing/2014/main" id="{2911F1D9-24F7-415B-A5C8-EA572034E041}"/>
               </a:ext>
             </a:extLst>
           </p:cNvPr>
@@ -6920,7 +6994,7 @@
           <p:cNvPr id="2" name="">
             <a:extLst xmlns:a="http://schemas.openxmlformats.org/drawingml/2006/main">
               <a:ext uri="{FF2B5EF4-FFF2-40B4-BE49-F238E27FC236}">
-                <a16:creationId xmlns:a16="http://schemas.microsoft.com/office/drawing/2014/main" id="{A60C3700-D066-46BA-873D-1033C31DF0F5}"/>
+                <a16:creationId xmlns:a16="http://schemas.microsoft.com/office/drawing/2014/main" id="{C2D9789C-CE2F-4A0B-84F1-EDEA8DB9B580}"/>
               </a:ext>
             </a:extLst>
           </p:cNvPr>
@@ -6986,7 +7060,7 @@
           <p:cNvPr id="3" name="">
             <a:extLst xmlns:a="http://schemas.openxmlformats.org/drawingml/2006/main">
               <a:ext uri="{FF2B5EF4-FFF2-40B4-BE49-F238E27FC236}">
-                <a16:creationId xmlns:a16="http://schemas.microsoft.com/office/drawing/2014/main" id="{936FE6A2-91A6-464D-A6A6-431AD7C9338B}"/>
+                <a16:creationId xmlns:a16="http://schemas.microsoft.com/office/drawing/2014/main" id="{186F5599-5731-4332-8DDA-65096634B4C4}"/>
               </a:ext>
             </a:extLst>
           </p:cNvPr>
@@ -7052,7 +7126,7 @@
           <p:cNvPr id="4" name="">
             <a:extLst xmlns:a="http://schemas.openxmlformats.org/drawingml/2006/main">
               <a:ext uri="{FF2B5EF4-FFF2-40B4-BE49-F238E27FC236}">
-                <a16:creationId xmlns:a16="http://schemas.microsoft.com/office/drawing/2014/main" id="{CC3339FF-0003-4D2A-B515-E390D62A3353}"/>
+                <a16:creationId xmlns:a16="http://schemas.microsoft.com/office/drawing/2014/main" id="{18E6468C-40E0-4400-AF2B-3E47F5239D36}"/>
               </a:ext>
             </a:extLst>
           </p:cNvPr>
@@ -7118,7 +7192,7 @@
           <p:cNvPr id="5" name="">
             <a:extLst xmlns:a="http://schemas.openxmlformats.org/drawingml/2006/main">
               <a:ext uri="{FF2B5EF4-FFF2-40B4-BE49-F238E27FC236}">
-                <a16:creationId xmlns:a16="http://schemas.microsoft.com/office/drawing/2014/main" id="{C283BBEC-1984-4A38-AAFD-4B27AB9B831B}"/>
+                <a16:creationId xmlns:a16="http://schemas.microsoft.com/office/drawing/2014/main" id="{AE91669F-677B-4195-8EE5-50F39D162097}"/>
               </a:ext>
             </a:extLst>
           </p:cNvPr>
@@ -7184,7 +7258,7 @@
           <p:cNvPr id="6" name="">
             <a:extLst xmlns:a="http://schemas.openxmlformats.org/drawingml/2006/main">
               <a:ext uri="{FF2B5EF4-FFF2-40B4-BE49-F238E27FC236}">
-                <a16:creationId xmlns:a16="http://schemas.microsoft.com/office/drawing/2014/main" id="{A0122CC2-89D5-42BD-88B6-1CB7A4C18B24}"/>
+                <a16:creationId xmlns:a16="http://schemas.microsoft.com/office/drawing/2014/main" id="{4C0EBD65-C126-400D-A0C4-A841FDAACA36}"/>
               </a:ext>
             </a:extLst>
           </p:cNvPr>
@@ -7248,7 +7322,7 @@
     </p:spTree>
     <p:extLst>
       <p:ext uri="{BB962C8B-B14F-4D97-AF65-F5344CB8AC3E}">
-        <p14:creationId xmlns:p14="http://schemas.microsoft.com/office/powerpoint/2010/main" val="1733388912"/>
+        <p14:creationId xmlns:p14="http://schemas.microsoft.com/office/powerpoint/2010/main" val="1859609516"/>
       </p:ext>
     </p:extLst>
   </p:cSld>
@@ -7279,7 +7353,7 @@
           <p:cNvPr id="7" name="">
             <a:extLst xmlns:a="http://schemas.openxmlformats.org/drawingml/2006/main">
               <a:ext uri="{FF2B5EF4-FFF2-40B4-BE49-F238E27FC236}">
-                <a16:creationId xmlns:a16="http://schemas.microsoft.com/office/drawing/2014/main" id="{FC79BEEC-546D-44E7-9D4E-6D37DAED87BF}"/>
+                <a16:creationId xmlns:a16="http://schemas.microsoft.com/office/drawing/2014/main" id="{A2B52696-BD89-4A2F-8591-984514313B15}"/>
               </a:ext>
             </a:extLst>
           </p:cNvPr>
@@ -7345,7 +7419,7 @@
           <p:cNvPr id="2" name="">
             <a:extLst xmlns:a="http://schemas.openxmlformats.org/drawingml/2006/main">
               <a:ext uri="{FF2B5EF4-FFF2-40B4-BE49-F238E27FC236}">
-                <a16:creationId xmlns:a16="http://schemas.microsoft.com/office/drawing/2014/main" id="{C9B713CF-92F1-4334-851B-EB30CF10863A}"/>
+                <a16:creationId xmlns:a16="http://schemas.microsoft.com/office/drawing/2014/main" id="{617FC22F-D8AB-40D2-9477-18932FA2E020}"/>
               </a:ext>
             </a:extLst>
           </p:cNvPr>
@@ -7411,7 +7485,7 @@
           <p:cNvPr id="3" name="">
             <a:extLst xmlns:a="http://schemas.openxmlformats.org/drawingml/2006/main">
               <a:ext uri="{FF2B5EF4-FFF2-40B4-BE49-F238E27FC236}">
-                <a16:creationId xmlns:a16="http://schemas.microsoft.com/office/drawing/2014/main" id="{26BF22EC-FEDB-4D84-AB45-97480DED2271}"/>
+                <a16:creationId xmlns:a16="http://schemas.microsoft.com/office/drawing/2014/main" id="{5AF6ADF6-AEAB-4397-A951-941ED2087D6D}"/>
               </a:ext>
             </a:extLst>
           </p:cNvPr>
@@ -7477,7 +7551,7 @@
           <p:cNvPr id="4" name="">
             <a:extLst xmlns:a="http://schemas.openxmlformats.org/drawingml/2006/main">
               <a:ext uri="{FF2B5EF4-FFF2-40B4-BE49-F238E27FC236}">
-                <a16:creationId xmlns:a16="http://schemas.microsoft.com/office/drawing/2014/main" id="{9EA4AD6C-1506-4279-9090-A304A3AC7296}"/>
+                <a16:creationId xmlns:a16="http://schemas.microsoft.com/office/drawing/2014/main" id="{77025734-4B07-4716-A9A1-42812A3E2BFF}"/>
               </a:ext>
             </a:extLst>
           </p:cNvPr>
@@ -7543,7 +7617,7 @@
           <p:cNvPr id="5" name="">
             <a:extLst xmlns:a="http://schemas.openxmlformats.org/drawingml/2006/main">
               <a:ext uri="{FF2B5EF4-FFF2-40B4-BE49-F238E27FC236}">
-                <a16:creationId xmlns:a16="http://schemas.microsoft.com/office/drawing/2014/main" id="{8497B5F5-5DD6-4563-AA50-A8DACF790764}"/>
+                <a16:creationId xmlns:a16="http://schemas.microsoft.com/office/drawing/2014/main" id="{3CCA5A92-A017-46C9-8485-64707510AF48}"/>
               </a:ext>
             </a:extLst>
           </p:cNvPr>
@@ -7599,7 +7673,7 @@
                 <a:ea typeface="Arial"/>
                 <a:cs typeface="Arial"/>
               </a:rPr>
-              <a:t>DCLP3 is an offline 30/60-minute numerical study. Event replay uses excluded evaluation folds; operational alerts remain disabled.</a:t>
+              <a:t>Patient replay uses saved models and the fold that excluded this patient. Research decisions remain separate from clinical alerts.</a:t>
             </a:r>
           </a:p>
         </p:txBody>
@@ -7609,7 +7683,7 @@
           <p:cNvPr id="6" name="">
             <a:extLst xmlns:a="http://schemas.openxmlformats.org/drawingml/2006/main">
               <a:ext uri="{FF2B5EF4-FFF2-40B4-BE49-F238E27FC236}">
-                <a16:creationId xmlns:a16="http://schemas.microsoft.com/office/drawing/2014/main" id="{5DA01270-AF14-43E9-BF40-C5D7DA982D9B}"/>
+                <a16:creationId xmlns:a16="http://schemas.microsoft.com/office/drawing/2014/main" id="{EBD8CE02-F293-48AA-986C-CC95E08F9007}"/>
               </a:ext>
             </a:extLst>
           </p:cNvPr>
@@ -7673,7 +7747,7 @@
     </p:spTree>
     <p:extLst>
       <p:ext uri="{BB962C8B-B14F-4D97-AF65-F5344CB8AC3E}">
-        <p14:creationId xmlns:p14="http://schemas.microsoft.com/office/powerpoint/2010/main" val="141241815"/>
+        <p14:creationId xmlns:p14="http://schemas.microsoft.com/office/powerpoint/2010/main" val="356029976"/>
       </p:ext>
     </p:extLst>
   </p:cSld>
@@ -7704,7 +7778,7 @@
           <p:cNvPr id="8" name="">
             <a:extLst xmlns:a="http://schemas.openxmlformats.org/drawingml/2006/main">
               <a:ext uri="{FF2B5EF4-FFF2-40B4-BE49-F238E27FC236}">
-                <a16:creationId xmlns:a16="http://schemas.microsoft.com/office/drawing/2014/main" id="{4DC6F449-139B-4579-956D-E8F60EA2F92B}"/>
+                <a16:creationId xmlns:a16="http://schemas.microsoft.com/office/drawing/2014/main" id="{57B89037-1935-4729-B06B-20EF781BA40C}"/>
               </a:ext>
             </a:extLst>
           </p:cNvPr>
@@ -7770,7 +7844,7 @@
           <p:cNvPr id="2" name="">
             <a:extLst xmlns:a="http://schemas.openxmlformats.org/drawingml/2006/main">
               <a:ext uri="{FF2B5EF4-FFF2-40B4-BE49-F238E27FC236}">
-                <a16:creationId xmlns:a16="http://schemas.microsoft.com/office/drawing/2014/main" id="{21572032-0EE6-44D5-AA9B-FAC46702FF73}"/>
+                <a16:creationId xmlns:a16="http://schemas.microsoft.com/office/drawing/2014/main" id="{1AE0A1F6-CC93-4731-B95B-2D78DC2D38E8}"/>
               </a:ext>
             </a:extLst>
           </p:cNvPr>
@@ -7836,7 +7910,7 @@
           <p:cNvPr id="3" name="">
             <a:extLst xmlns:a="http://schemas.openxmlformats.org/drawingml/2006/main">
               <a:ext uri="{FF2B5EF4-FFF2-40B4-BE49-F238E27FC236}">
-                <a16:creationId xmlns:a16="http://schemas.microsoft.com/office/drawing/2014/main" id="{90746D60-4417-4780-9ACA-60EBBE814348}"/>
+                <a16:creationId xmlns:a16="http://schemas.microsoft.com/office/drawing/2014/main" id="{31EA66E2-2ED4-46E9-8177-97C3561C07A2}"/>
               </a:ext>
             </a:extLst>
           </p:cNvPr>
@@ -7902,7 +7976,7 @@
           <p:cNvPr id="4" name="">
             <a:extLst xmlns:a="http://schemas.openxmlformats.org/drawingml/2006/main">
               <a:ext uri="{FF2B5EF4-FFF2-40B4-BE49-F238E27FC236}">
-                <a16:creationId xmlns:a16="http://schemas.microsoft.com/office/drawing/2014/main" id="{9B69F3E9-1FF0-49F2-A7FD-A458C3CD23F8}"/>
+                <a16:creationId xmlns:a16="http://schemas.microsoft.com/office/drawing/2014/main" id="{04301E88-329D-40AB-8604-64835A94FD18}"/>
               </a:ext>
             </a:extLst>
           </p:cNvPr>
@@ -7968,7 +8042,7 @@
           <p:cNvPr id="5" name="">
             <a:extLst xmlns:a="http://schemas.openxmlformats.org/drawingml/2006/main">
               <a:ext uri="{FF2B5EF4-FFF2-40B4-BE49-F238E27FC236}">
-                <a16:creationId xmlns:a16="http://schemas.microsoft.com/office/drawing/2014/main" id="{EC59637E-F327-4379-A82A-2F320396A33D}"/>
+                <a16:creationId xmlns:a16="http://schemas.microsoft.com/office/drawing/2014/main" id="{2714E461-FDD0-4F19-B5FD-D943D6A40511}"/>
               </a:ext>
             </a:extLst>
           </p:cNvPr>
@@ -8034,7 +8108,7 @@
           <p:cNvPr id="6" name="">
             <a:extLst xmlns:a="http://schemas.openxmlformats.org/drawingml/2006/main">
               <a:ext uri="{FF2B5EF4-FFF2-40B4-BE49-F238E27FC236}">
-                <a16:creationId xmlns:a16="http://schemas.microsoft.com/office/drawing/2014/main" id="{A5474652-78AB-4105-87C8-01D5577B8ADC}"/>
+                <a16:creationId xmlns:a16="http://schemas.microsoft.com/office/drawing/2014/main" id="{83FBAD2E-551C-483F-BBA1-BF21B6A648DC}"/>
               </a:ext>
             </a:extLst>
           </p:cNvPr>
@@ -8100,7 +8174,7 @@
           <p:cNvPr id="7" name="">
             <a:extLst xmlns:a="http://schemas.openxmlformats.org/drawingml/2006/main">
               <a:ext uri="{FF2B5EF4-FFF2-40B4-BE49-F238E27FC236}">
-                <a16:creationId xmlns:a16="http://schemas.microsoft.com/office/drawing/2014/main" id="{285F9C5E-6A97-494A-B767-309D04952CC8}"/>
+                <a16:creationId xmlns:a16="http://schemas.microsoft.com/office/drawing/2014/main" id="{1C6735B5-7DC2-4AC0-9372-1242025FEF04}"/>
               </a:ext>
             </a:extLst>
           </p:cNvPr>
@@ -8164,7 +8238,7 @@
     </p:spTree>
     <p:extLst>
       <p:ext uri="{BB962C8B-B14F-4D97-AF65-F5344CB8AC3E}">
-        <p14:creationId xmlns:p14="http://schemas.microsoft.com/office/powerpoint/2010/main" val="508189666"/>
+        <p14:creationId xmlns:p14="http://schemas.microsoft.com/office/powerpoint/2010/main" val="2042091267"/>
       </p:ext>
     </p:extLst>
   </p:cSld>
@@ -8195,7 +8269,7 @@
           <p:cNvPr id="7" name="">
             <a:extLst xmlns:a="http://schemas.openxmlformats.org/drawingml/2006/main">
               <a:ext uri="{FF2B5EF4-FFF2-40B4-BE49-F238E27FC236}">
-                <a16:creationId xmlns:a16="http://schemas.microsoft.com/office/drawing/2014/main" id="{2497E77B-2CB6-42B1-B4AF-83521E2586D3}"/>
+                <a16:creationId xmlns:a16="http://schemas.microsoft.com/office/drawing/2014/main" id="{0A7D9EDE-5BCD-4618-B7C5-9D39E0A874DF}"/>
               </a:ext>
             </a:extLst>
           </p:cNvPr>
@@ -8261,7 +8335,7 @@
           <p:cNvPr id="2" name="">
             <a:extLst xmlns:a="http://schemas.openxmlformats.org/drawingml/2006/main">
               <a:ext uri="{FF2B5EF4-FFF2-40B4-BE49-F238E27FC236}">
-                <a16:creationId xmlns:a16="http://schemas.microsoft.com/office/drawing/2014/main" id="{78E6C2A4-DB51-4C0C-B9D3-1DA55C02926D}"/>
+                <a16:creationId xmlns:a16="http://schemas.microsoft.com/office/drawing/2014/main" id="{56492298-3C3A-452D-8E93-D598ADACE82A}"/>
               </a:ext>
             </a:extLst>
           </p:cNvPr>
@@ -8327,7 +8401,7 @@
           <p:cNvPr id="3" name="">
             <a:extLst xmlns:a="http://schemas.openxmlformats.org/drawingml/2006/main">
               <a:ext uri="{FF2B5EF4-FFF2-40B4-BE49-F238E27FC236}">
-                <a16:creationId xmlns:a16="http://schemas.microsoft.com/office/drawing/2014/main" id="{6F0105E2-9880-4642-94FE-8784BCCC8182}"/>
+                <a16:creationId xmlns:a16="http://schemas.microsoft.com/office/drawing/2014/main" id="{CF581BAD-36B7-4822-A8AC-2AF13DD49BC1}"/>
               </a:ext>
             </a:extLst>
           </p:cNvPr>
@@ -8393,7 +8467,7 @@
           <p:cNvPr id="4" name="">
             <a:extLst xmlns:a="http://schemas.openxmlformats.org/drawingml/2006/main">
               <a:ext uri="{FF2B5EF4-FFF2-40B4-BE49-F238E27FC236}">
-                <a16:creationId xmlns:a16="http://schemas.microsoft.com/office/drawing/2014/main" id="{3DD5BDE3-321D-4493-BF2B-469377143F3A}"/>
+                <a16:creationId xmlns:a16="http://schemas.microsoft.com/office/drawing/2014/main" id="{4522AA75-8BB6-4025-993C-94C823E6F22D}"/>
               </a:ext>
             </a:extLst>
           </p:cNvPr>
@@ -8459,7 +8533,7 @@
           <p:cNvPr id="5" name="">
             <a:extLst xmlns:a="http://schemas.openxmlformats.org/drawingml/2006/main">
               <a:ext uri="{FF2B5EF4-FFF2-40B4-BE49-F238E27FC236}">
-                <a16:creationId xmlns:a16="http://schemas.microsoft.com/office/drawing/2014/main" id="{9C31E9EF-CF30-4BA7-8C31-E7F1FA201940}"/>
+                <a16:creationId xmlns:a16="http://schemas.microsoft.com/office/drawing/2014/main" id="{913B68C4-E47C-48DD-B345-5EF6BFAA58B7}"/>
               </a:ext>
             </a:extLst>
           </p:cNvPr>
@@ -8525,7 +8599,7 @@
           <p:cNvPr id="6" name="">
             <a:extLst xmlns:a="http://schemas.openxmlformats.org/drawingml/2006/main">
               <a:ext uri="{FF2B5EF4-FFF2-40B4-BE49-F238E27FC236}">
-                <a16:creationId xmlns:a16="http://schemas.microsoft.com/office/drawing/2014/main" id="{72A05C5F-728D-4729-A1B5-BDCF93DAE663}"/>
+                <a16:creationId xmlns:a16="http://schemas.microsoft.com/office/drawing/2014/main" id="{26B56598-DB80-4EE7-9AD6-C90E911FDF9D}"/>
               </a:ext>
             </a:extLst>
           </p:cNvPr>
@@ -8589,7 +8663,7 @@
     </p:spTree>
     <p:extLst>
       <p:ext uri="{BB962C8B-B14F-4D97-AF65-F5344CB8AC3E}">
-        <p14:creationId xmlns:p14="http://schemas.microsoft.com/office/powerpoint/2010/main" val="1315348911"/>
+        <p14:creationId xmlns:p14="http://schemas.microsoft.com/office/powerpoint/2010/main" val="1925237307"/>
       </p:ext>
     </p:extLst>
   </p:cSld>
@@ -8620,7 +8694,7 @@
           <p:cNvPr id="6" name="">
             <a:extLst xmlns:a="http://schemas.openxmlformats.org/drawingml/2006/main">
               <a:ext uri="{FF2B5EF4-FFF2-40B4-BE49-F238E27FC236}">
-                <a16:creationId xmlns:a16="http://schemas.microsoft.com/office/drawing/2014/main" id="{08599041-D171-41C2-A65E-EB30A5DBBB8B}"/>
+                <a16:creationId xmlns:a16="http://schemas.microsoft.com/office/drawing/2014/main" id="{6B7D93BC-CE7B-40E5-97B3-24AF99F7E5C0}"/>
               </a:ext>
             </a:extLst>
           </p:cNvPr>
@@ -8686,7 +8760,7 @@
           <p:cNvPr id="2" name="">
             <a:extLst xmlns:a="http://schemas.openxmlformats.org/drawingml/2006/main">
               <a:ext uri="{FF2B5EF4-FFF2-40B4-BE49-F238E27FC236}">
-                <a16:creationId xmlns:a16="http://schemas.microsoft.com/office/drawing/2014/main" id="{7C27C704-680C-49A1-8F8A-6C64FEABEF8A}"/>
+                <a16:creationId xmlns:a16="http://schemas.microsoft.com/office/drawing/2014/main" id="{002E5F80-F787-40C1-AEA7-F8C72EBE6DA0}"/>
               </a:ext>
             </a:extLst>
           </p:cNvPr>
@@ -8752,7 +8826,7 @@
           <p:cNvPr id="3" name="">
             <a:extLst xmlns:a="http://schemas.openxmlformats.org/drawingml/2006/main">
               <a:ext uri="{FF2B5EF4-FFF2-40B4-BE49-F238E27FC236}">
-                <a16:creationId xmlns:a16="http://schemas.microsoft.com/office/drawing/2014/main" id="{EF38E6C5-D4BF-4D64-A38E-AC4BD12111F0}"/>
+                <a16:creationId xmlns:a16="http://schemas.microsoft.com/office/drawing/2014/main" id="{46CE40FB-4EAC-4E27-BB17-5A076C24D639}"/>
               </a:ext>
             </a:extLst>
           </p:cNvPr>
@@ -9030,7 +9104,7 @@
           <p:cNvPr id="4" name="">
             <a:extLst xmlns:a="http://schemas.openxmlformats.org/drawingml/2006/main">
               <a:ext uri="{FF2B5EF4-FFF2-40B4-BE49-F238E27FC236}">
-                <a16:creationId xmlns:a16="http://schemas.microsoft.com/office/drawing/2014/main" id="{E765CD3E-5678-4341-A584-470287A3A07E}"/>
+                <a16:creationId xmlns:a16="http://schemas.microsoft.com/office/drawing/2014/main" id="{18DA9F4F-E44D-4E07-8B39-642938AA74C0}"/>
               </a:ext>
             </a:extLst>
           </p:cNvPr>
@@ -9096,7 +9170,7 @@
           <p:cNvPr id="5" name="">
             <a:extLst xmlns:a="http://schemas.openxmlformats.org/drawingml/2006/main">
               <a:ext uri="{FF2B5EF4-FFF2-40B4-BE49-F238E27FC236}">
-                <a16:creationId xmlns:a16="http://schemas.microsoft.com/office/drawing/2014/main" id="{DA4BE161-5A9A-4A4D-988E-F114E173C098}"/>
+                <a16:creationId xmlns:a16="http://schemas.microsoft.com/office/drawing/2014/main" id="{3A03D22D-99D1-428F-AAD3-6F62FE2473B8}"/>
               </a:ext>
             </a:extLst>
           </p:cNvPr>
@@ -9160,7 +9234,7 @@
     </p:spTree>
     <p:extLst>
       <p:ext uri="{BB962C8B-B14F-4D97-AF65-F5344CB8AC3E}">
-        <p14:creationId xmlns:p14="http://schemas.microsoft.com/office/powerpoint/2010/main" val="933676238"/>
+        <p14:creationId xmlns:p14="http://schemas.microsoft.com/office/powerpoint/2010/main" val="407725094"/>
       </p:ext>
     </p:extLst>
   </p:cSld>

</xml_diff>